<commit_message>
Make a custom image filter
</commit_message>
<xml_diff>
--- a/.lessons/35 Packages İntervention Image/2 Make a custom image filter/1.pptx
+++ b/.lessons/35 Packages İntervention Image/2 Make a custom image filter/1.pptx
@@ -6,8 +6,16 @@
   </p:sldMasterIdLst>
   <p:sldIdLst>
     <p:sldId id="402" r:id="rId2"/>
-    <p:sldId id="403" r:id="rId3"/>
-    <p:sldId id="400" r:id="rId4"/>
+    <p:sldId id="406" r:id="rId3"/>
+    <p:sldId id="404" r:id="rId4"/>
+    <p:sldId id="405" r:id="rId5"/>
+    <p:sldId id="403" r:id="rId6"/>
+    <p:sldId id="400" r:id="rId7"/>
+    <p:sldId id="407" r:id="rId8"/>
+    <p:sldId id="408" r:id="rId9"/>
+    <p:sldId id="409" r:id="rId10"/>
+    <p:sldId id="410" r:id="rId11"/>
+    <p:sldId id="411" r:id="rId12"/>
   </p:sldIdLst>
   <p:sldSz cx="12192000" cy="6858000"/>
   <p:notesSz cx="6858000" cy="9144000"/>
@@ -261,7 +269,7 @@
           <a:p>
             <a:fld id="{3E102D2E-813C-461C-9963-687A650C48C0}" type="datetimeFigureOut">
               <a:rPr lang="en-US" smtClean="0"/>
-              <a:t>5/23/2025</a:t>
+              <a:t>6/18/2025</a:t>
             </a:fld>
             <a:endParaRPr lang="en-US"/>
           </a:p>
@@ -459,7 +467,7 @@
           <a:p>
             <a:fld id="{3E102D2E-813C-461C-9963-687A650C48C0}" type="datetimeFigureOut">
               <a:rPr lang="en-US" smtClean="0"/>
-              <a:t>5/23/2025</a:t>
+              <a:t>6/18/2025</a:t>
             </a:fld>
             <a:endParaRPr lang="en-US"/>
           </a:p>
@@ -667,7 +675,7 @@
           <a:p>
             <a:fld id="{3E102D2E-813C-461C-9963-687A650C48C0}" type="datetimeFigureOut">
               <a:rPr lang="en-US" smtClean="0"/>
-              <a:t>5/23/2025</a:t>
+              <a:t>6/18/2025</a:t>
             </a:fld>
             <a:endParaRPr lang="en-US"/>
           </a:p>
@@ -865,7 +873,7 @@
           <a:p>
             <a:fld id="{3E102D2E-813C-461C-9963-687A650C48C0}" type="datetimeFigureOut">
               <a:rPr lang="en-US" smtClean="0"/>
-              <a:t>5/23/2025</a:t>
+              <a:t>6/18/2025</a:t>
             </a:fld>
             <a:endParaRPr lang="en-US"/>
           </a:p>
@@ -1140,7 +1148,7 @@
           <a:p>
             <a:fld id="{3E102D2E-813C-461C-9963-687A650C48C0}" type="datetimeFigureOut">
               <a:rPr lang="en-US" smtClean="0"/>
-              <a:t>5/23/2025</a:t>
+              <a:t>6/18/2025</a:t>
             </a:fld>
             <a:endParaRPr lang="en-US"/>
           </a:p>
@@ -1405,7 +1413,7 @@
           <a:p>
             <a:fld id="{3E102D2E-813C-461C-9963-687A650C48C0}" type="datetimeFigureOut">
               <a:rPr lang="en-US" smtClean="0"/>
-              <a:t>5/23/2025</a:t>
+              <a:t>6/18/2025</a:t>
             </a:fld>
             <a:endParaRPr lang="en-US"/>
           </a:p>
@@ -1817,7 +1825,7 @@
           <a:p>
             <a:fld id="{3E102D2E-813C-461C-9963-687A650C48C0}" type="datetimeFigureOut">
               <a:rPr lang="en-US" smtClean="0"/>
-              <a:t>5/23/2025</a:t>
+              <a:t>6/18/2025</a:t>
             </a:fld>
             <a:endParaRPr lang="en-US"/>
           </a:p>
@@ -1958,7 +1966,7 @@
           <a:p>
             <a:fld id="{3E102D2E-813C-461C-9963-687A650C48C0}" type="datetimeFigureOut">
               <a:rPr lang="en-US" smtClean="0"/>
-              <a:t>5/23/2025</a:t>
+              <a:t>6/18/2025</a:t>
             </a:fld>
             <a:endParaRPr lang="en-US"/>
           </a:p>
@@ -2071,7 +2079,7 @@
           <a:p>
             <a:fld id="{3E102D2E-813C-461C-9963-687A650C48C0}" type="datetimeFigureOut">
               <a:rPr lang="en-US" smtClean="0"/>
-              <a:t>5/23/2025</a:t>
+              <a:t>6/18/2025</a:t>
             </a:fld>
             <a:endParaRPr lang="en-US"/>
           </a:p>
@@ -2382,7 +2390,7 @@
           <a:p>
             <a:fld id="{3E102D2E-813C-461C-9963-687A650C48C0}" type="datetimeFigureOut">
               <a:rPr lang="en-US" smtClean="0"/>
-              <a:t>5/23/2025</a:t>
+              <a:t>6/18/2025</a:t>
             </a:fld>
             <a:endParaRPr lang="en-US"/>
           </a:p>
@@ -2670,7 +2678,7 @@
           <a:p>
             <a:fld id="{3E102D2E-813C-461C-9963-687A650C48C0}" type="datetimeFigureOut">
               <a:rPr lang="en-US" smtClean="0"/>
-              <a:t>5/23/2025</a:t>
+              <a:t>6/18/2025</a:t>
             </a:fld>
             <a:endParaRPr lang="en-US"/>
           </a:p>
@@ -2911,7 +2919,7 @@
           <a:p>
             <a:fld id="{3E102D2E-813C-461C-9963-687A650C48C0}" type="datetimeFigureOut">
               <a:rPr lang="en-US" smtClean="0"/>
-              <a:t>5/23/2025</a:t>
+              <a:t>6/18/2025</a:t>
             </a:fld>
             <a:endParaRPr lang="en-US"/>
           </a:p>
@@ -3348,8 +3356,8 @@
         </p:nvSpPr>
         <p:spPr>
           <a:xfrm>
-            <a:off x="217714" y="255046"/>
-            <a:ext cx="11756571" cy="355354"/>
+            <a:off x="217714" y="171071"/>
+            <a:ext cx="8114523" cy="6429132"/>
           </a:xfrm>
           <a:prstGeom prst="rect">
             <a:avLst/>
@@ -3369,7 +3377,218 @@
               <a:buNone/>
             </a:pPr>
             <a:r>
-              <a:rPr kumimoji="0" lang="en-US" altLang="en-US" sz="1300" b="0" i="0" u="none" strike="noStrike" cap="none" normalizeH="0" baseline="0">
+              <a:rPr lang="az-Latn-AZ" altLang="en-US" sz="1200">
+                <a:latin typeface="Arial" panose="020B0604020202020204" pitchFamily="34" charset="0"/>
+              </a:rPr>
+              <a:t>Bu dərs, şəkil (image) üzərində xüsusi emal (processing) əməliyyatlarını mərkəzləşdirmək və təkrar istifadə etmək üçün köməkçinin (helper -in) necə yazıldığını öyrənəcəyik.</a:t>
+            </a:r>
+          </a:p>
+          <a:p>
+            <a:pPr>
+              <a:lnSpc>
+                <a:spcPct val="150000"/>
+              </a:lnSpc>
+              <a:buNone/>
+            </a:pPr>
+            <a:endParaRPr kumimoji="0" lang="az-Latn-AZ" altLang="en-US" sz="1200" b="0" i="0" u="none" strike="noStrike" cap="none" normalizeH="0" baseline="0">
+              <a:ln>
+                <a:noFill/>
+              </a:ln>
+              <a:solidFill>
+                <a:schemeClr val="tx1"/>
+              </a:solidFill>
+              <a:effectLst/>
+              <a:latin typeface="Arial" panose="020B0604020202020204" pitchFamily="34" charset="0"/>
+            </a:endParaRPr>
+          </a:p>
+          <a:p>
+            <a:pPr>
+              <a:lnSpc>
+                <a:spcPct val="150000"/>
+              </a:lnSpc>
+              <a:buNone/>
+            </a:pPr>
+            <a:endParaRPr lang="az-Latn-AZ" altLang="en-US" sz="1200">
+              <a:latin typeface="Arial" panose="020B0604020202020204" pitchFamily="34" charset="0"/>
+            </a:endParaRPr>
+          </a:p>
+          <a:p>
+            <a:pPr>
+              <a:lnSpc>
+                <a:spcPct val="150000"/>
+              </a:lnSpc>
+              <a:buNone/>
+            </a:pPr>
+            <a:r>
+              <a:rPr lang="en-US" altLang="en-US" sz="1200">
+                <a:latin typeface="Arial" panose="020B0604020202020204" pitchFamily="34" charset="0"/>
+              </a:rPr>
+              <a:t>✅ </a:t>
+            </a:r>
+            <a:r>
+              <a:rPr lang="en-US" altLang="en-US" sz="1200" b="1">
+                <a:latin typeface="Arial" panose="020B0604020202020204" pitchFamily="34" charset="0"/>
+              </a:rPr>
+              <a:t>Əsas məqsəd </a:t>
+            </a:r>
+            <a:r>
+              <a:rPr lang="az-Latn-AZ" altLang="en-US" sz="1200" b="1">
+                <a:latin typeface="Arial" panose="020B0604020202020204" pitchFamily="34" charset="0"/>
+              </a:rPr>
+              <a:t>k</a:t>
+            </a:r>
+            <a:r>
+              <a:rPr lang="en-US" altLang="en-US" sz="1200" b="1">
+                <a:latin typeface="Arial" panose="020B0604020202020204" pitchFamily="34" charset="0"/>
+              </a:rPr>
+              <a:t>odun təmiz və modulyar olması</a:t>
+            </a:r>
+            <a:endParaRPr lang="az-Latn-AZ" altLang="en-US" sz="1200" b="1">
+              <a:latin typeface="Arial" panose="020B0604020202020204" pitchFamily="34" charset="0"/>
+            </a:endParaRPr>
+          </a:p>
+          <a:p>
+            <a:pPr>
+              <a:lnSpc>
+                <a:spcPct val="150000"/>
+              </a:lnSpc>
+              <a:buNone/>
+            </a:pPr>
+            <a:endParaRPr lang="en-US" altLang="en-US" sz="1200" b="1">
+              <a:latin typeface="Arial" panose="020B0604020202020204" pitchFamily="34" charset="0"/>
+            </a:endParaRPr>
+          </a:p>
+          <a:p>
+            <a:pPr>
+              <a:lnSpc>
+                <a:spcPct val="150000"/>
+              </a:lnSpc>
+              <a:buNone/>
+            </a:pPr>
+            <a:r>
+              <a:rPr lang="en-US" altLang="en-US" sz="1200">
+                <a:latin typeface="Arial" panose="020B0604020202020204" pitchFamily="34" charset="0"/>
+              </a:rPr>
+              <a:t>Laravel-də </a:t>
+            </a:r>
+            <a:r>
+              <a:rPr lang="en-US" altLang="en-US" sz="1200" b="1">
+                <a:latin typeface="Arial" panose="020B0604020202020204" pitchFamily="34" charset="0"/>
+              </a:rPr>
+              <a:t>routes/web.php </a:t>
+            </a:r>
+            <a:r>
+              <a:rPr lang="en-US" altLang="en-US" sz="1200">
+                <a:latin typeface="Arial" panose="020B0604020202020204" pitchFamily="34" charset="0"/>
+              </a:rPr>
+              <a:t>və ya controller daxilində uzun şəkil emal kodlarını yazmaq əvəzinə, bu əməliyyatları </a:t>
+            </a:r>
+            <a:r>
+              <a:rPr lang="en-US" altLang="en-US" sz="1200" b="1">
+                <a:latin typeface="Arial" panose="020B0604020202020204" pitchFamily="34" charset="0"/>
+              </a:rPr>
+              <a:t>app/Helpers/ImageFilter.php </a:t>
+            </a:r>
+            <a:r>
+              <a:rPr lang="en-US" altLang="en-US" sz="1200">
+                <a:latin typeface="Arial" panose="020B0604020202020204" pitchFamily="34" charset="0"/>
+              </a:rPr>
+              <a:t>faylına keçirməklə:</a:t>
+            </a:r>
+          </a:p>
+          <a:p>
+            <a:pPr marL="742950" lvl="1" indent="-285750">
+              <a:lnSpc>
+                <a:spcPct val="150000"/>
+              </a:lnSpc>
+              <a:buFont typeface="Arial" panose="020B0604020202020204" pitchFamily="34" charset="0"/>
+              <a:buChar char="•"/>
+            </a:pPr>
+            <a:r>
+              <a:rPr lang="en-US" altLang="en-US" sz="1200">
+                <a:latin typeface="Arial" panose="020B0604020202020204" pitchFamily="34" charset="0"/>
+              </a:rPr>
+              <a:t>Kod oxunaqlı olur</a:t>
+            </a:r>
+          </a:p>
+          <a:p>
+            <a:pPr marL="742950" lvl="1" indent="-285750">
+              <a:lnSpc>
+                <a:spcPct val="150000"/>
+              </a:lnSpc>
+              <a:buFont typeface="Arial" panose="020B0604020202020204" pitchFamily="34" charset="0"/>
+              <a:buChar char="•"/>
+            </a:pPr>
+            <a:r>
+              <a:rPr lang="en-US" altLang="en-US" sz="1200">
+                <a:latin typeface="Arial" panose="020B0604020202020204" pitchFamily="34" charset="0"/>
+              </a:rPr>
+              <a:t>Funksiya təkrar istifadə oluna bilir</a:t>
+            </a:r>
+          </a:p>
+          <a:p>
+            <a:pPr marL="742950" lvl="1" indent="-285750">
+              <a:lnSpc>
+                <a:spcPct val="150000"/>
+              </a:lnSpc>
+              <a:buFont typeface="Arial" panose="020B0604020202020204" pitchFamily="34" charset="0"/>
+              <a:buChar char="•"/>
+            </a:pPr>
+            <a:r>
+              <a:rPr lang="en-US" altLang="en-US" sz="1200">
+                <a:latin typeface="Arial" panose="020B0604020202020204" pitchFamily="34" charset="0"/>
+              </a:rPr>
+              <a:t>Test yazmaq və dəyişiklik etmək daha asanlaşır</a:t>
+            </a:r>
+            <a:endParaRPr lang="az-Latn-AZ" altLang="en-US" sz="1200">
+              <a:latin typeface="Arial" panose="020B0604020202020204" pitchFamily="34" charset="0"/>
+            </a:endParaRPr>
+          </a:p>
+          <a:p>
+            <a:pPr>
+              <a:lnSpc>
+                <a:spcPct val="150000"/>
+              </a:lnSpc>
+              <a:buNone/>
+            </a:pPr>
+            <a:endParaRPr kumimoji="0" lang="az-Latn-AZ" altLang="en-US" sz="1200" b="0" i="0" u="none" strike="noStrike" cap="none" normalizeH="0" baseline="0">
+              <a:ln>
+                <a:noFill/>
+              </a:ln>
+              <a:solidFill>
+                <a:schemeClr val="tx1"/>
+              </a:solidFill>
+              <a:effectLst/>
+              <a:latin typeface="Arial" panose="020B0604020202020204" pitchFamily="34" charset="0"/>
+            </a:endParaRPr>
+          </a:p>
+          <a:p>
+            <a:pPr>
+              <a:lnSpc>
+                <a:spcPct val="150000"/>
+              </a:lnSpc>
+              <a:buNone/>
+            </a:pPr>
+            <a:endParaRPr kumimoji="0" lang="az-Latn-AZ" altLang="en-US" sz="1200" b="0" i="0" u="none" strike="noStrike" cap="none" normalizeH="0" baseline="0">
+              <a:ln>
+                <a:noFill/>
+              </a:ln>
+              <a:solidFill>
+                <a:schemeClr val="tx1"/>
+              </a:solidFill>
+              <a:effectLst/>
+              <a:latin typeface="Arial" panose="020B0604020202020204" pitchFamily="34" charset="0"/>
+            </a:endParaRPr>
+          </a:p>
+          <a:p>
+            <a:pPr>
+              <a:lnSpc>
+                <a:spcPct val="150000"/>
+              </a:lnSpc>
+              <a:buNone/>
+            </a:pPr>
+            <a:r>
+              <a:rPr kumimoji="0" lang="az-Latn-AZ" altLang="en-US" sz="1200" b="0" i="0" u="none" strike="noStrike" cap="none" normalizeH="0" baseline="0">
                 <a:ln>
                   <a:noFill/>
                 </a:ln>
@@ -3379,11 +3598,221 @@
                 <a:effectLst/>
                 <a:latin typeface="Arial" panose="020B0604020202020204" pitchFamily="34" charset="0"/>
               </a:rPr>
-              <a:t>.</a:t>
-            </a:r>
-          </a:p>
-        </p:txBody>
-      </p:sp>
+              <a:t>Biz indi, </a:t>
+            </a:r>
+            <a:r>
+              <a:rPr kumimoji="0" lang="en-US" altLang="en-US" sz="1200" b="1" i="0" u="none" strike="noStrike" cap="none" normalizeH="0" baseline="0">
+                <a:ln>
+                  <a:noFill/>
+                </a:ln>
+                <a:solidFill>
+                  <a:schemeClr val="tx1"/>
+                </a:solidFill>
+                <a:effectLst/>
+                <a:latin typeface="Arial" panose="020B0604020202020204" pitchFamily="34" charset="0"/>
+              </a:rPr>
+              <a:t>web.php </a:t>
+            </a:r>
+            <a:r>
+              <a:rPr lang="az-Latn-AZ" altLang="en-US" sz="1200">
+                <a:latin typeface="Arial" panose="020B0604020202020204" pitchFamily="34" charset="0"/>
+              </a:rPr>
+              <a:t>faylında yazılan və şəkli </a:t>
+            </a:r>
+            <a:r>
+              <a:rPr lang="az-Latn-AZ" altLang="en-US" sz="1200" b="1">
+                <a:latin typeface="Arial" panose="020B0604020202020204" pitchFamily="34" charset="0"/>
+              </a:rPr>
+              <a:t>filter</a:t>
+            </a:r>
+            <a:r>
+              <a:rPr lang="az-Latn-AZ" altLang="en-US" sz="1200">
+                <a:latin typeface="Arial" panose="020B0604020202020204" pitchFamily="34" charset="0"/>
+              </a:rPr>
+              <a:t> etmək üçün istifadə edilən artıq kodları `</a:t>
+            </a:r>
+            <a:r>
+              <a:rPr lang="az-Latn-AZ" altLang="en-US" sz="1200" b="1">
+                <a:solidFill>
+                  <a:srgbClr val="FF0000"/>
+                </a:solidFill>
+                <a:latin typeface="Arial" panose="020B0604020202020204" pitchFamily="34" charset="0"/>
+              </a:rPr>
+              <a:t>app\Helpers\ImageFilter.php</a:t>
+            </a:r>
+            <a:r>
+              <a:rPr lang="az-Latn-AZ" altLang="en-US" sz="1200">
+                <a:latin typeface="Arial" panose="020B0604020202020204" pitchFamily="34" charset="0"/>
+              </a:rPr>
+              <a:t>` adında </a:t>
+            </a:r>
+            <a:r>
+              <a:rPr lang="az-Latn-AZ" altLang="en-US" sz="1200" b="1">
+                <a:solidFill>
+                  <a:srgbClr val="FF0000"/>
+                </a:solidFill>
+                <a:latin typeface="Arial" panose="020B0604020202020204" pitchFamily="34" charset="0"/>
+              </a:rPr>
+              <a:t>helper</a:t>
+            </a:r>
+            <a:r>
+              <a:rPr lang="az-Latn-AZ" altLang="en-US" sz="1200">
+                <a:latin typeface="Arial" panose="020B0604020202020204" pitchFamily="34" charset="0"/>
+              </a:rPr>
+              <a:t> yaradaraq bu faylın içinə yerləşdirəcəyik.</a:t>
+            </a:r>
+          </a:p>
+          <a:p>
+            <a:pPr>
+              <a:lnSpc>
+                <a:spcPct val="150000"/>
+              </a:lnSpc>
+              <a:buNone/>
+            </a:pPr>
+            <a:endParaRPr kumimoji="0" lang="az-Latn-AZ" altLang="en-US" sz="1200" b="0" i="0" u="none" strike="noStrike" cap="none" normalizeH="0" baseline="0">
+              <a:ln>
+                <a:noFill/>
+              </a:ln>
+              <a:solidFill>
+                <a:schemeClr val="tx1"/>
+              </a:solidFill>
+              <a:effectLst/>
+              <a:latin typeface="Arial" panose="020B0604020202020204" pitchFamily="34" charset="0"/>
+            </a:endParaRPr>
+          </a:p>
+          <a:p>
+            <a:pPr>
+              <a:lnSpc>
+                <a:spcPct val="150000"/>
+              </a:lnSpc>
+              <a:buNone/>
+            </a:pPr>
+            <a:r>
+              <a:rPr lang="az-Latn-AZ" altLang="en-US" sz="1200" b="1">
+                <a:latin typeface="Arial" panose="020B0604020202020204" pitchFamily="34" charset="0"/>
+              </a:rPr>
+              <a:t>V3</a:t>
+            </a:r>
+            <a:r>
+              <a:rPr lang="az-Latn-AZ" altLang="en-US" sz="1200">
+                <a:latin typeface="Arial" panose="020B0604020202020204" pitchFamily="34" charset="0"/>
+              </a:rPr>
+              <a:t> versiyasında Filter üçün istifadə edilən bölməni tapmaq çətin ola bilər. Ancaq </a:t>
+            </a:r>
+            <a:r>
+              <a:rPr lang="az-Latn-AZ" altLang="en-US" sz="1200" b="1">
+                <a:latin typeface="Arial" panose="020B0604020202020204" pitchFamily="34" charset="0"/>
+              </a:rPr>
+              <a:t>V2</a:t>
+            </a:r>
+            <a:r>
+              <a:rPr lang="az-Latn-AZ" altLang="en-US" sz="1200">
+                <a:latin typeface="Arial" panose="020B0604020202020204" pitchFamily="34" charset="0"/>
+              </a:rPr>
+              <a:t> versiyasında sol tərəfdə `</a:t>
+            </a:r>
+            <a:r>
+              <a:rPr lang="az-Latn-AZ" altLang="en-US" sz="1200" b="1">
+                <a:latin typeface="Arial" panose="020B0604020202020204" pitchFamily="34" charset="0"/>
+              </a:rPr>
+              <a:t>Image Filters</a:t>
+            </a:r>
+            <a:r>
+              <a:rPr lang="az-Latn-AZ" altLang="en-US" sz="1200">
+                <a:latin typeface="Arial" panose="020B0604020202020204" pitchFamily="34" charset="0"/>
+              </a:rPr>
+              <a:t>` deyilən bir yazı var. Bu səhifəyə keçərək kodları kopyala və </a:t>
+            </a:r>
+            <a:r>
+              <a:rPr lang="az-Latn-AZ" altLang="en-US" sz="1200" b="1">
+                <a:solidFill>
+                  <a:srgbClr val="FF0000"/>
+                </a:solidFill>
+                <a:latin typeface="Arial" panose="020B0604020202020204" pitchFamily="34" charset="0"/>
+              </a:rPr>
+              <a:t>ImageFilter.php </a:t>
+            </a:r>
+            <a:r>
+              <a:rPr lang="az-Latn-AZ" altLang="en-US" sz="1200">
+                <a:latin typeface="Arial" panose="020B0604020202020204" pitchFamily="34" charset="0"/>
+              </a:rPr>
+              <a:t>faylına yerləşdirə bilərik. Təbiki versiya fərqinə görə həmin kodlar üzərində dəyişikliklər etmək lazım gələcək. </a:t>
+            </a:r>
+          </a:p>
+          <a:p>
+            <a:pPr>
+              <a:lnSpc>
+                <a:spcPct val="150000"/>
+              </a:lnSpc>
+              <a:buNone/>
+            </a:pPr>
+            <a:endParaRPr kumimoji="0" lang="az-Latn-AZ" altLang="en-US" sz="1200" b="0" i="0" u="none" strike="noStrike" cap="none" normalizeH="0" baseline="0">
+              <a:ln>
+                <a:noFill/>
+              </a:ln>
+              <a:solidFill>
+                <a:schemeClr val="tx1"/>
+              </a:solidFill>
+              <a:effectLst/>
+              <a:latin typeface="Arial" panose="020B0604020202020204" pitchFamily="34" charset="0"/>
+            </a:endParaRPr>
+          </a:p>
+          <a:p>
+            <a:pPr>
+              <a:lnSpc>
+                <a:spcPct val="150000"/>
+              </a:lnSpc>
+              <a:buNone/>
+            </a:pPr>
+            <a:r>
+              <a:rPr lang="az-Latn-AZ" altLang="en-US" sz="1200">
+                <a:latin typeface="Arial" panose="020B0604020202020204" pitchFamily="34" charset="0"/>
+              </a:rPr>
+              <a:t>Hətta olanları tamamən öz ürəyiniz istiyən kimi dəyişdirə bilərsiz. Çünki bu cür Helperləri heç hardansa kod nümunəsi götürmədən, öz ağlımızdan da yaza bilərik. Əsas lazım olan isə bu Helper -i necə çağırmaq lazımdır necə dəyər ötürə bilərik və.s kimi primitiv məsələlərdir.</a:t>
+            </a:r>
+            <a:endParaRPr kumimoji="0" lang="en-US" altLang="en-US" sz="1200" b="0" i="0" u="none" strike="noStrike" cap="none" normalizeH="0" baseline="0">
+              <a:ln>
+                <a:noFill/>
+              </a:ln>
+              <a:solidFill>
+                <a:schemeClr val="tx1"/>
+              </a:solidFill>
+              <a:effectLst/>
+              <a:latin typeface="Arial" panose="020B0604020202020204" pitchFamily="34" charset="0"/>
+            </a:endParaRPr>
+          </a:p>
+        </p:txBody>
+      </p:sp>
+      <p:pic>
+        <p:nvPicPr>
+          <p:cNvPr id="4" name="Picture 3">
+            <a:extLst>
+              <a:ext uri="{FF2B5EF4-FFF2-40B4-BE49-F238E27FC236}">
+                <a16:creationId xmlns:a16="http://schemas.microsoft.com/office/drawing/2014/main" id="{68D8B8FB-BEB4-FE09-8CE6-E865D4022BB0}"/>
+              </a:ext>
+            </a:extLst>
+          </p:cNvPr>
+          <p:cNvPicPr>
+            <a:picLocks noChangeAspect="1"/>
+          </p:cNvPicPr>
+          <p:nvPr/>
+        </p:nvPicPr>
+        <p:blipFill>
+          <a:blip r:embed="rId2"/>
+          <a:stretch>
+            <a:fillRect/>
+          </a:stretch>
+        </p:blipFill>
+        <p:spPr>
+          <a:xfrm>
+            <a:off x="8612855" y="0"/>
+            <a:ext cx="3579145" cy="6858000"/>
+          </a:xfrm>
+          <a:prstGeom prst="rect">
+            <a:avLst/>
+          </a:prstGeom>
+        </p:spPr>
+      </p:pic>
     </p:spTree>
     <p:extLst>
       <p:ext uri="{BB962C8B-B14F-4D97-AF65-F5344CB8AC3E}">
@@ -3397,7 +3826,533 @@
 </p:sld>
 </file>
 
+<file path=ppt/slides/slide10.xml><?xml version="1.0" encoding="utf-8"?>
+<p:sld xmlns:a="http://schemas.openxmlformats.org/drawingml/2006/main" xmlns:r="http://schemas.openxmlformats.org/officeDocument/2006/relationships" xmlns:p="http://schemas.openxmlformats.org/presentationml/2006/main">
+  <p:cSld>
+    <p:spTree>
+      <p:nvGrpSpPr>
+        <p:cNvPr id="1" name="">
+          <a:extLst>
+            <a:ext uri="{FF2B5EF4-FFF2-40B4-BE49-F238E27FC236}">
+              <a16:creationId xmlns:a16="http://schemas.microsoft.com/office/drawing/2014/main" id="{803B4FEA-B2E0-C06D-1599-D41F786213B5}"/>
+            </a:ext>
+          </a:extLst>
+        </p:cNvPr>
+        <p:cNvGrpSpPr/>
+        <p:nvPr/>
+      </p:nvGrpSpPr>
+      <p:grpSpPr>
+        <a:xfrm>
+          <a:off x="0" y="0"/>
+          <a:ext cx="0" cy="0"/>
+          <a:chOff x="0" y="0"/>
+          <a:chExt cx="0" cy="0"/>
+        </a:xfrm>
+      </p:grpSpPr>
+      <p:sp>
+        <p:nvSpPr>
+          <p:cNvPr id="3" name="TextBox 2">
+            <a:extLst>
+              <a:ext uri="{FF2B5EF4-FFF2-40B4-BE49-F238E27FC236}">
+                <a16:creationId xmlns:a16="http://schemas.microsoft.com/office/drawing/2014/main" id="{96F63940-17BC-C5EC-6D9E-6A9C05A5A4C3}"/>
+              </a:ext>
+            </a:extLst>
+          </p:cNvPr>
+          <p:cNvSpPr txBox="1"/>
+          <p:nvPr/>
+        </p:nvSpPr>
+        <p:spPr>
+          <a:xfrm>
+            <a:off x="217714" y="255046"/>
+            <a:ext cx="11756571" cy="355354"/>
+          </a:xfrm>
+          <a:prstGeom prst="rect">
+            <a:avLst/>
+          </a:prstGeom>
+          <a:noFill/>
+        </p:spPr>
+        <p:txBody>
+          <a:bodyPr wrap="square">
+            <a:spAutoFit/>
+          </a:bodyPr>
+          <a:lstStyle/>
+          <a:p>
+            <a:pPr>
+              <a:lnSpc>
+                <a:spcPct val="150000"/>
+              </a:lnSpc>
+              <a:buNone/>
+            </a:pPr>
+            <a:r>
+              <a:rPr kumimoji="0" lang="en-US" altLang="en-US" sz="1300" b="0" i="0" u="none" strike="noStrike" cap="none" normalizeH="0" baseline="0">
+                <a:ln>
+                  <a:noFill/>
+                </a:ln>
+                <a:solidFill>
+                  <a:schemeClr val="tx1"/>
+                </a:solidFill>
+                <a:effectLst/>
+                <a:latin typeface="Arial" panose="020B0604020202020204" pitchFamily="34" charset="0"/>
+              </a:rPr>
+              <a:t>.</a:t>
+            </a:r>
+          </a:p>
+        </p:txBody>
+      </p:sp>
+    </p:spTree>
+    <p:extLst>
+      <p:ext uri="{BB962C8B-B14F-4D97-AF65-F5344CB8AC3E}">
+        <p14:creationId xmlns:p14="http://schemas.microsoft.com/office/powerpoint/2010/main" val="2559581218"/>
+      </p:ext>
+    </p:extLst>
+  </p:cSld>
+  <p:clrMapOvr>
+    <a:masterClrMapping/>
+  </p:clrMapOvr>
+</p:sld>
+</file>
+
+<file path=ppt/slides/slide11.xml><?xml version="1.0" encoding="utf-8"?>
+<p:sld xmlns:a="http://schemas.openxmlformats.org/drawingml/2006/main" xmlns:r="http://schemas.openxmlformats.org/officeDocument/2006/relationships" xmlns:p="http://schemas.openxmlformats.org/presentationml/2006/main">
+  <p:cSld>
+    <p:spTree>
+      <p:nvGrpSpPr>
+        <p:cNvPr id="1" name="">
+          <a:extLst>
+            <a:ext uri="{FF2B5EF4-FFF2-40B4-BE49-F238E27FC236}">
+              <a16:creationId xmlns:a16="http://schemas.microsoft.com/office/drawing/2014/main" id="{692C19A3-37FA-47DA-71AB-E31E2D5FEC09}"/>
+            </a:ext>
+          </a:extLst>
+        </p:cNvPr>
+        <p:cNvGrpSpPr/>
+        <p:nvPr/>
+      </p:nvGrpSpPr>
+      <p:grpSpPr>
+        <a:xfrm>
+          <a:off x="0" y="0"/>
+          <a:ext cx="0" cy="0"/>
+          <a:chOff x="0" y="0"/>
+          <a:chExt cx="0" cy="0"/>
+        </a:xfrm>
+      </p:grpSpPr>
+      <p:sp>
+        <p:nvSpPr>
+          <p:cNvPr id="3" name="TextBox 2">
+            <a:extLst>
+              <a:ext uri="{FF2B5EF4-FFF2-40B4-BE49-F238E27FC236}">
+                <a16:creationId xmlns:a16="http://schemas.microsoft.com/office/drawing/2014/main" id="{FB5321D6-F220-AB50-EE92-BF9F5F1D346A}"/>
+              </a:ext>
+            </a:extLst>
+          </p:cNvPr>
+          <p:cNvSpPr txBox="1"/>
+          <p:nvPr/>
+        </p:nvSpPr>
+        <p:spPr>
+          <a:xfrm>
+            <a:off x="217714" y="255046"/>
+            <a:ext cx="11756571" cy="355354"/>
+          </a:xfrm>
+          <a:prstGeom prst="rect">
+            <a:avLst/>
+          </a:prstGeom>
+          <a:noFill/>
+        </p:spPr>
+        <p:txBody>
+          <a:bodyPr wrap="square">
+            <a:spAutoFit/>
+          </a:bodyPr>
+          <a:lstStyle/>
+          <a:p>
+            <a:pPr>
+              <a:lnSpc>
+                <a:spcPct val="150000"/>
+              </a:lnSpc>
+              <a:buNone/>
+            </a:pPr>
+            <a:r>
+              <a:rPr kumimoji="0" lang="en-US" altLang="en-US" sz="1300" b="0" i="0" u="none" strike="noStrike" cap="none" normalizeH="0" baseline="0">
+                <a:ln>
+                  <a:noFill/>
+                </a:ln>
+                <a:solidFill>
+                  <a:schemeClr val="tx1"/>
+                </a:solidFill>
+                <a:effectLst/>
+                <a:latin typeface="Arial" panose="020B0604020202020204" pitchFamily="34" charset="0"/>
+              </a:rPr>
+              <a:t>.</a:t>
+            </a:r>
+          </a:p>
+        </p:txBody>
+      </p:sp>
+    </p:spTree>
+    <p:extLst>
+      <p:ext uri="{BB962C8B-B14F-4D97-AF65-F5344CB8AC3E}">
+        <p14:creationId xmlns:p14="http://schemas.microsoft.com/office/powerpoint/2010/main" val="2279035771"/>
+      </p:ext>
+    </p:extLst>
+  </p:cSld>
+  <p:clrMapOvr>
+    <a:masterClrMapping/>
+  </p:clrMapOvr>
+</p:sld>
+</file>
+
 <file path=ppt/slides/slide2.xml><?xml version="1.0" encoding="utf-8"?>
+<p:sld xmlns:a="http://schemas.openxmlformats.org/drawingml/2006/main" xmlns:r="http://schemas.openxmlformats.org/officeDocument/2006/relationships" xmlns:p="http://schemas.openxmlformats.org/presentationml/2006/main">
+  <p:cSld>
+    <p:spTree>
+      <p:nvGrpSpPr>
+        <p:cNvPr id="1" name="">
+          <a:extLst>
+            <a:ext uri="{FF2B5EF4-FFF2-40B4-BE49-F238E27FC236}">
+              <a16:creationId xmlns:a16="http://schemas.microsoft.com/office/drawing/2014/main" id="{2AC79D2A-F25D-8795-3861-DD0D44330726}"/>
+            </a:ext>
+          </a:extLst>
+        </p:cNvPr>
+        <p:cNvGrpSpPr/>
+        <p:nvPr/>
+      </p:nvGrpSpPr>
+      <p:grpSpPr>
+        <a:xfrm>
+          <a:off x="0" y="0"/>
+          <a:ext cx="0" cy="0"/>
+          <a:chOff x="0" y="0"/>
+          <a:chExt cx="0" cy="0"/>
+        </a:xfrm>
+      </p:grpSpPr>
+      <p:sp>
+        <p:nvSpPr>
+          <p:cNvPr id="3" name="TextBox 2">
+            <a:extLst>
+              <a:ext uri="{FF2B5EF4-FFF2-40B4-BE49-F238E27FC236}">
+                <a16:creationId xmlns:a16="http://schemas.microsoft.com/office/drawing/2014/main" id="{C6886E52-D248-D598-662B-871DBDB627B0}"/>
+              </a:ext>
+            </a:extLst>
+          </p:cNvPr>
+          <p:cNvSpPr txBox="1"/>
+          <p:nvPr/>
+        </p:nvSpPr>
+        <p:spPr>
+          <a:xfrm>
+            <a:off x="217714" y="255046"/>
+            <a:ext cx="11756571" cy="355354"/>
+          </a:xfrm>
+          <a:prstGeom prst="rect">
+            <a:avLst/>
+          </a:prstGeom>
+          <a:noFill/>
+        </p:spPr>
+        <p:txBody>
+          <a:bodyPr wrap="square">
+            <a:spAutoFit/>
+          </a:bodyPr>
+          <a:lstStyle/>
+          <a:p>
+            <a:pPr>
+              <a:lnSpc>
+                <a:spcPct val="150000"/>
+              </a:lnSpc>
+              <a:buNone/>
+            </a:pPr>
+            <a:r>
+              <a:rPr kumimoji="0" lang="en-US" altLang="en-US" sz="1300" b="0" i="0" u="none" strike="noStrike" cap="none" normalizeH="0" baseline="0">
+                <a:ln>
+                  <a:noFill/>
+                </a:ln>
+                <a:solidFill>
+                  <a:schemeClr val="tx1"/>
+                </a:solidFill>
+                <a:effectLst/>
+                <a:latin typeface="Arial" panose="020B0604020202020204" pitchFamily="34" charset="0"/>
+              </a:rPr>
+              <a:t>.</a:t>
+            </a:r>
+          </a:p>
+        </p:txBody>
+      </p:sp>
+      <p:pic>
+        <p:nvPicPr>
+          <p:cNvPr id="4" name="Picture 3">
+            <a:extLst>
+              <a:ext uri="{FF2B5EF4-FFF2-40B4-BE49-F238E27FC236}">
+                <a16:creationId xmlns:a16="http://schemas.microsoft.com/office/drawing/2014/main" id="{7BF82AD3-373D-EDB5-3E8E-AE019DE7B407}"/>
+              </a:ext>
+            </a:extLst>
+          </p:cNvPr>
+          <p:cNvPicPr>
+            <a:picLocks noChangeAspect="1"/>
+          </p:cNvPicPr>
+          <p:nvPr/>
+        </p:nvPicPr>
+        <p:blipFill>
+          <a:blip r:embed="rId2"/>
+          <a:stretch>
+            <a:fillRect/>
+          </a:stretch>
+        </p:blipFill>
+        <p:spPr>
+          <a:xfrm>
+            <a:off x="3982146" y="0"/>
+            <a:ext cx="8209854" cy="6858000"/>
+          </a:xfrm>
+          <a:prstGeom prst="rect">
+            <a:avLst/>
+          </a:prstGeom>
+        </p:spPr>
+      </p:pic>
+    </p:spTree>
+    <p:extLst>
+      <p:ext uri="{BB962C8B-B14F-4D97-AF65-F5344CB8AC3E}">
+        <p14:creationId xmlns:p14="http://schemas.microsoft.com/office/powerpoint/2010/main" val="2153336709"/>
+      </p:ext>
+    </p:extLst>
+  </p:cSld>
+  <p:clrMapOvr>
+    <a:masterClrMapping/>
+  </p:clrMapOvr>
+</p:sld>
+</file>
+
+<file path=ppt/slides/slide3.xml><?xml version="1.0" encoding="utf-8"?>
+<p:sld xmlns:a="http://schemas.openxmlformats.org/drawingml/2006/main" xmlns:r="http://schemas.openxmlformats.org/officeDocument/2006/relationships" xmlns:p="http://schemas.openxmlformats.org/presentationml/2006/main">
+  <p:cSld>
+    <p:spTree>
+      <p:nvGrpSpPr>
+        <p:cNvPr id="1" name="">
+          <a:extLst>
+            <a:ext uri="{FF2B5EF4-FFF2-40B4-BE49-F238E27FC236}">
+              <a16:creationId xmlns:a16="http://schemas.microsoft.com/office/drawing/2014/main" id="{84738692-BC17-CD2A-1EFF-90359DB6DB46}"/>
+            </a:ext>
+          </a:extLst>
+        </p:cNvPr>
+        <p:cNvGrpSpPr/>
+        <p:nvPr/>
+      </p:nvGrpSpPr>
+      <p:grpSpPr>
+        <a:xfrm>
+          <a:off x="0" y="0"/>
+          <a:ext cx="0" cy="0"/>
+          <a:chOff x="0" y="0"/>
+          <a:chExt cx="0" cy="0"/>
+        </a:xfrm>
+      </p:grpSpPr>
+      <p:sp>
+        <p:nvSpPr>
+          <p:cNvPr id="3" name="TextBox 2">
+            <a:extLst>
+              <a:ext uri="{FF2B5EF4-FFF2-40B4-BE49-F238E27FC236}">
+                <a16:creationId xmlns:a16="http://schemas.microsoft.com/office/drawing/2014/main" id="{E47B1BAC-C5CB-8FEC-1466-463F797DAA0C}"/>
+              </a:ext>
+            </a:extLst>
+          </p:cNvPr>
+          <p:cNvSpPr txBox="1"/>
+          <p:nvPr/>
+        </p:nvSpPr>
+        <p:spPr>
+          <a:xfrm>
+            <a:off x="217714" y="40815"/>
+            <a:ext cx="11756571" cy="355354"/>
+          </a:xfrm>
+          <a:prstGeom prst="rect">
+            <a:avLst/>
+          </a:prstGeom>
+          <a:noFill/>
+        </p:spPr>
+        <p:txBody>
+          <a:bodyPr wrap="square">
+            <a:spAutoFit/>
+          </a:bodyPr>
+          <a:lstStyle/>
+          <a:p>
+            <a:pPr>
+              <a:lnSpc>
+                <a:spcPct val="150000"/>
+              </a:lnSpc>
+              <a:buNone/>
+            </a:pPr>
+            <a:r>
+              <a:rPr lang="az-Latn-AZ" altLang="en-US" sz="1300">
+                <a:latin typeface="Arial" panose="020B0604020202020204" pitchFamily="34" charset="0"/>
+              </a:rPr>
+              <a:t>Buda bizim modifikasiya edilmiş kodumuz.</a:t>
+            </a:r>
+            <a:endParaRPr kumimoji="0" lang="en-US" altLang="en-US" sz="1300" b="0" i="0" u="none" strike="noStrike" cap="none" normalizeH="0" baseline="0">
+              <a:ln>
+                <a:noFill/>
+              </a:ln>
+              <a:solidFill>
+                <a:schemeClr val="tx1"/>
+              </a:solidFill>
+              <a:effectLst/>
+              <a:latin typeface="Arial" panose="020B0604020202020204" pitchFamily="34" charset="0"/>
+            </a:endParaRPr>
+          </a:p>
+        </p:txBody>
+      </p:sp>
+      <p:pic>
+        <p:nvPicPr>
+          <p:cNvPr id="4" name="Picture 3">
+            <a:extLst>
+              <a:ext uri="{FF2B5EF4-FFF2-40B4-BE49-F238E27FC236}">
+                <a16:creationId xmlns:a16="http://schemas.microsoft.com/office/drawing/2014/main" id="{3F14603B-DBD5-60C2-83DF-9CC66151D1C3}"/>
+              </a:ext>
+            </a:extLst>
+          </p:cNvPr>
+          <p:cNvPicPr>
+            <a:picLocks noChangeAspect="1"/>
+          </p:cNvPicPr>
+          <p:nvPr/>
+        </p:nvPicPr>
+        <p:blipFill>
+          <a:blip r:embed="rId2"/>
+          <a:stretch>
+            <a:fillRect/>
+          </a:stretch>
+        </p:blipFill>
+        <p:spPr>
+          <a:xfrm>
+            <a:off x="0" y="414831"/>
+            <a:ext cx="12192000" cy="6443169"/>
+          </a:xfrm>
+          <a:prstGeom prst="rect">
+            <a:avLst/>
+          </a:prstGeom>
+        </p:spPr>
+      </p:pic>
+    </p:spTree>
+    <p:extLst>
+      <p:ext uri="{BB962C8B-B14F-4D97-AF65-F5344CB8AC3E}">
+        <p14:creationId xmlns:p14="http://schemas.microsoft.com/office/powerpoint/2010/main" val="834169415"/>
+      </p:ext>
+    </p:extLst>
+  </p:cSld>
+  <p:clrMapOvr>
+    <a:masterClrMapping/>
+  </p:clrMapOvr>
+</p:sld>
+</file>
+
+<file path=ppt/slides/slide4.xml><?xml version="1.0" encoding="utf-8"?>
+<p:sld xmlns:a="http://schemas.openxmlformats.org/drawingml/2006/main" xmlns:r="http://schemas.openxmlformats.org/officeDocument/2006/relationships" xmlns:p="http://schemas.openxmlformats.org/presentationml/2006/main">
+  <p:cSld>
+    <p:spTree>
+      <p:nvGrpSpPr>
+        <p:cNvPr id="1" name="">
+          <a:extLst>
+            <a:ext uri="{FF2B5EF4-FFF2-40B4-BE49-F238E27FC236}">
+              <a16:creationId xmlns:a16="http://schemas.microsoft.com/office/drawing/2014/main" id="{E842FB2B-5F06-6D85-BF43-F61AB2BD8068}"/>
+            </a:ext>
+          </a:extLst>
+        </p:cNvPr>
+        <p:cNvGrpSpPr/>
+        <p:nvPr/>
+      </p:nvGrpSpPr>
+      <p:grpSpPr>
+        <a:xfrm>
+          <a:off x="0" y="0"/>
+          <a:ext cx="0" cy="0"/>
+          <a:chOff x="0" y="0"/>
+          <a:chExt cx="0" cy="0"/>
+        </a:xfrm>
+      </p:grpSpPr>
+      <p:sp>
+        <p:nvSpPr>
+          <p:cNvPr id="3" name="TextBox 2">
+            <a:extLst>
+              <a:ext uri="{FF2B5EF4-FFF2-40B4-BE49-F238E27FC236}">
+                <a16:creationId xmlns:a16="http://schemas.microsoft.com/office/drawing/2014/main" id="{12A27B26-8A17-B541-C669-5148BEA1DB9C}"/>
+              </a:ext>
+            </a:extLst>
+          </p:cNvPr>
+          <p:cNvSpPr txBox="1"/>
+          <p:nvPr/>
+        </p:nvSpPr>
+        <p:spPr>
+          <a:xfrm>
+            <a:off x="217714" y="255046"/>
+            <a:ext cx="11756571" cy="355354"/>
+          </a:xfrm>
+          <a:prstGeom prst="rect">
+            <a:avLst/>
+          </a:prstGeom>
+          <a:noFill/>
+        </p:spPr>
+        <p:txBody>
+          <a:bodyPr wrap="square">
+            <a:spAutoFit/>
+          </a:bodyPr>
+          <a:lstStyle/>
+          <a:p>
+            <a:pPr>
+              <a:lnSpc>
+                <a:spcPct val="150000"/>
+              </a:lnSpc>
+              <a:buNone/>
+            </a:pPr>
+            <a:r>
+              <a:rPr lang="az-Latn-AZ" altLang="en-US" sz="1300">
+                <a:latin typeface="Arial" panose="020B0604020202020204" pitchFamily="34" charset="0"/>
+              </a:rPr>
+              <a:t>İstəsəniz kodu bu cürdə yaza bilərsiz. Dəyişən heç bir şey olmaycaq. Yanaşma fərqli nəticə isə eynidir.</a:t>
+            </a:r>
+            <a:endParaRPr kumimoji="0" lang="en-US" altLang="en-US" sz="1300" b="0" i="0" u="none" strike="noStrike" cap="none" normalizeH="0" baseline="0">
+              <a:ln>
+                <a:noFill/>
+              </a:ln>
+              <a:solidFill>
+                <a:schemeClr val="tx1"/>
+              </a:solidFill>
+              <a:effectLst/>
+              <a:latin typeface="Arial" panose="020B0604020202020204" pitchFamily="34" charset="0"/>
+            </a:endParaRPr>
+          </a:p>
+        </p:txBody>
+      </p:sp>
+      <p:pic>
+        <p:nvPicPr>
+          <p:cNvPr id="4" name="Picture 3">
+            <a:extLst>
+              <a:ext uri="{FF2B5EF4-FFF2-40B4-BE49-F238E27FC236}">
+                <a16:creationId xmlns:a16="http://schemas.microsoft.com/office/drawing/2014/main" id="{E11BDB7B-88CB-09DA-660D-CEF4E7B7EF85}"/>
+              </a:ext>
+            </a:extLst>
+          </p:cNvPr>
+          <p:cNvPicPr>
+            <a:picLocks noChangeAspect="1"/>
+          </p:cNvPicPr>
+          <p:nvPr/>
+        </p:nvPicPr>
+        <p:blipFill>
+          <a:blip r:embed="rId2"/>
+          <a:stretch>
+            <a:fillRect/>
+          </a:stretch>
+        </p:blipFill>
+        <p:spPr>
+          <a:xfrm>
+            <a:off x="0" y="999416"/>
+            <a:ext cx="12192000" cy="5858584"/>
+          </a:xfrm>
+          <a:prstGeom prst="rect">
+            <a:avLst/>
+          </a:prstGeom>
+        </p:spPr>
+      </p:pic>
+    </p:spTree>
+    <p:extLst>
+      <p:ext uri="{BB962C8B-B14F-4D97-AF65-F5344CB8AC3E}">
+        <p14:creationId xmlns:p14="http://schemas.microsoft.com/office/powerpoint/2010/main" val="4285506314"/>
+      </p:ext>
+    </p:extLst>
+  </p:cSld>
+  <p:clrMapOvr>
+    <a:masterClrMapping/>
+  </p:clrMapOvr>
+</p:sld>
+</file>
+
+<file path=ppt/slides/slide5.xml><?xml version="1.0" encoding="utf-8"?>
 <p:sld xmlns:a="http://schemas.openxmlformats.org/drawingml/2006/main" xmlns:r="http://schemas.openxmlformats.org/officeDocument/2006/relationships" xmlns:p="http://schemas.openxmlformats.org/presentationml/2006/main">
   <p:cSld>
     <p:spTree>
@@ -3455,21 +4410,84 @@
               <a:buNone/>
             </a:pPr>
             <a:r>
-              <a:rPr kumimoji="0" lang="en-US" altLang="en-US" sz="1300" b="0" i="0" u="none" strike="noStrike" cap="none" normalizeH="0" baseline="0">
-                <a:ln>
-                  <a:noFill/>
-                </a:ln>
-                <a:solidFill>
-                  <a:schemeClr val="tx1"/>
-                </a:solidFill>
-                <a:effectLst/>
+              <a:rPr lang="en-US" altLang="en-US" sz="1300">
                 <a:latin typeface="Arial" panose="020B0604020202020204" pitchFamily="34" charset="0"/>
               </a:rPr>
-              <a:t>.</a:t>
-            </a:r>
-          </a:p>
-        </p:txBody>
-      </p:sp>
+              <a:t>Yaxud </a:t>
+            </a:r>
+            <a:r>
+              <a:rPr lang="en-US" altLang="en-US" sz="1300" b="1">
+                <a:latin typeface="Arial" panose="020B0604020202020204" pitchFamily="34" charset="0"/>
+              </a:rPr>
+              <a:t>$this-&gt; </a:t>
+            </a:r>
+            <a:r>
+              <a:rPr lang="en-US" altLang="en-US" sz="1300">
+                <a:latin typeface="Arial" panose="020B0604020202020204" pitchFamily="34" charset="0"/>
+              </a:rPr>
+              <a:t>ilə </a:t>
+            </a:r>
+            <a:r>
+              <a:rPr lang="en-US" altLang="en-US" sz="1300" b="1">
+                <a:latin typeface="Arial" panose="020B0604020202020204" pitchFamily="34" charset="0"/>
+              </a:rPr>
+              <a:t>non-static</a:t>
+            </a:r>
+            <a:r>
+              <a:rPr lang="en-US" altLang="en-US" sz="1300">
+                <a:latin typeface="Arial" panose="020B0604020202020204" pitchFamily="34" charset="0"/>
+              </a:rPr>
+              <a:t> qaydada da müraciət </a:t>
+            </a:r>
+            <a:r>
+              <a:rPr lang="az-Latn-AZ" altLang="en-US" sz="1300">
+                <a:latin typeface="Arial" panose="020B0604020202020204" pitchFamily="34" charset="0"/>
+              </a:rPr>
+              <a:t>edə bilərik.</a:t>
+            </a:r>
+            <a:endParaRPr kumimoji="0" lang="en-US" altLang="en-US" sz="1300" b="0" i="0" u="none" strike="noStrike" cap="none" normalizeH="0" baseline="0">
+              <a:ln>
+                <a:noFill/>
+              </a:ln>
+              <a:solidFill>
+                <a:schemeClr val="tx1"/>
+              </a:solidFill>
+              <a:effectLst/>
+              <a:latin typeface="Arial" panose="020B0604020202020204" pitchFamily="34" charset="0"/>
+            </a:endParaRPr>
+          </a:p>
+        </p:txBody>
+      </p:sp>
+      <p:pic>
+        <p:nvPicPr>
+          <p:cNvPr id="4" name="Picture 3">
+            <a:extLst>
+              <a:ext uri="{FF2B5EF4-FFF2-40B4-BE49-F238E27FC236}">
+                <a16:creationId xmlns:a16="http://schemas.microsoft.com/office/drawing/2014/main" id="{C4F32203-F2CF-D33C-AFC7-F976A289AF29}"/>
+              </a:ext>
+            </a:extLst>
+          </p:cNvPr>
+          <p:cNvPicPr>
+            <a:picLocks noChangeAspect="1"/>
+          </p:cNvPicPr>
+          <p:nvPr/>
+        </p:nvPicPr>
+        <p:blipFill>
+          <a:blip r:embed="rId2"/>
+          <a:stretch>
+            <a:fillRect/>
+          </a:stretch>
+        </p:blipFill>
+        <p:spPr>
+          <a:xfrm>
+            <a:off x="-1" y="1030378"/>
+            <a:ext cx="12192000" cy="5827622"/>
+          </a:xfrm>
+          <a:prstGeom prst="rect">
+            <a:avLst/>
+          </a:prstGeom>
+        </p:spPr>
+      </p:pic>
     </p:spTree>
     <p:extLst>
       <p:ext uri="{BB962C8B-B14F-4D97-AF65-F5344CB8AC3E}">
@@ -3483,7 +4501,7 @@
 </p:sld>
 </file>
 
-<file path=ppt/slides/slide3.xml><?xml version="1.0" encoding="utf-8"?>
+<file path=ppt/slides/slide6.xml><?xml version="1.0" encoding="utf-8"?>
 <p:sld xmlns:a="http://schemas.openxmlformats.org/drawingml/2006/main" xmlns:r="http://schemas.openxmlformats.org/officeDocument/2006/relationships" xmlns:p="http://schemas.openxmlformats.org/presentationml/2006/main">
   <p:cSld>
     <p:spTree>
@@ -3560,6 +4578,264 @@
     <p:extLst>
       <p:ext uri="{BB962C8B-B14F-4D97-AF65-F5344CB8AC3E}">
         <p14:creationId xmlns:p14="http://schemas.microsoft.com/office/powerpoint/2010/main" val="3095838342"/>
+      </p:ext>
+    </p:extLst>
+  </p:cSld>
+  <p:clrMapOvr>
+    <a:masterClrMapping/>
+  </p:clrMapOvr>
+</p:sld>
+</file>
+
+<file path=ppt/slides/slide7.xml><?xml version="1.0" encoding="utf-8"?>
+<p:sld xmlns:a="http://schemas.openxmlformats.org/drawingml/2006/main" xmlns:r="http://schemas.openxmlformats.org/officeDocument/2006/relationships" xmlns:p="http://schemas.openxmlformats.org/presentationml/2006/main">
+  <p:cSld>
+    <p:spTree>
+      <p:nvGrpSpPr>
+        <p:cNvPr id="1" name="">
+          <a:extLst>
+            <a:ext uri="{FF2B5EF4-FFF2-40B4-BE49-F238E27FC236}">
+              <a16:creationId xmlns:a16="http://schemas.microsoft.com/office/drawing/2014/main" id="{44CF18FE-5A4D-2E01-48CB-6572D0F9F306}"/>
+            </a:ext>
+          </a:extLst>
+        </p:cNvPr>
+        <p:cNvGrpSpPr/>
+        <p:nvPr/>
+      </p:nvGrpSpPr>
+      <p:grpSpPr>
+        <a:xfrm>
+          <a:off x="0" y="0"/>
+          <a:ext cx="0" cy="0"/>
+          <a:chOff x="0" y="0"/>
+          <a:chExt cx="0" cy="0"/>
+        </a:xfrm>
+      </p:grpSpPr>
+      <p:sp>
+        <p:nvSpPr>
+          <p:cNvPr id="3" name="TextBox 2">
+            <a:extLst>
+              <a:ext uri="{FF2B5EF4-FFF2-40B4-BE49-F238E27FC236}">
+                <a16:creationId xmlns:a16="http://schemas.microsoft.com/office/drawing/2014/main" id="{CD3169BA-9C38-E906-A76F-740811BFC310}"/>
+              </a:ext>
+            </a:extLst>
+          </p:cNvPr>
+          <p:cNvSpPr txBox="1"/>
+          <p:nvPr/>
+        </p:nvSpPr>
+        <p:spPr>
+          <a:xfrm>
+            <a:off x="217714" y="255046"/>
+            <a:ext cx="11756571" cy="355354"/>
+          </a:xfrm>
+          <a:prstGeom prst="rect">
+            <a:avLst/>
+          </a:prstGeom>
+          <a:noFill/>
+        </p:spPr>
+        <p:txBody>
+          <a:bodyPr wrap="square">
+            <a:spAutoFit/>
+          </a:bodyPr>
+          <a:lstStyle/>
+          <a:p>
+            <a:pPr>
+              <a:lnSpc>
+                <a:spcPct val="150000"/>
+              </a:lnSpc>
+              <a:buNone/>
+            </a:pPr>
+            <a:r>
+              <a:rPr kumimoji="0" lang="en-US" altLang="en-US" sz="1300" b="0" i="0" u="none" strike="noStrike" cap="none" normalizeH="0" baseline="0">
+                <a:ln>
+                  <a:noFill/>
+                </a:ln>
+                <a:solidFill>
+                  <a:schemeClr val="tx1"/>
+                </a:solidFill>
+                <a:effectLst/>
+                <a:latin typeface="Arial" panose="020B0604020202020204" pitchFamily="34" charset="0"/>
+              </a:rPr>
+              <a:t>.</a:t>
+            </a:r>
+          </a:p>
+        </p:txBody>
+      </p:sp>
+    </p:spTree>
+    <p:extLst>
+      <p:ext uri="{BB962C8B-B14F-4D97-AF65-F5344CB8AC3E}">
+        <p14:creationId xmlns:p14="http://schemas.microsoft.com/office/powerpoint/2010/main" val="1546984614"/>
+      </p:ext>
+    </p:extLst>
+  </p:cSld>
+  <p:clrMapOvr>
+    <a:masterClrMapping/>
+  </p:clrMapOvr>
+</p:sld>
+</file>
+
+<file path=ppt/slides/slide8.xml><?xml version="1.0" encoding="utf-8"?>
+<p:sld xmlns:a="http://schemas.openxmlformats.org/drawingml/2006/main" xmlns:r="http://schemas.openxmlformats.org/officeDocument/2006/relationships" xmlns:p="http://schemas.openxmlformats.org/presentationml/2006/main">
+  <p:cSld>
+    <p:spTree>
+      <p:nvGrpSpPr>
+        <p:cNvPr id="1" name="">
+          <a:extLst>
+            <a:ext uri="{FF2B5EF4-FFF2-40B4-BE49-F238E27FC236}">
+              <a16:creationId xmlns:a16="http://schemas.microsoft.com/office/drawing/2014/main" id="{7196B0A1-EAF0-C37D-E8B1-CFB754F96300}"/>
+            </a:ext>
+          </a:extLst>
+        </p:cNvPr>
+        <p:cNvGrpSpPr/>
+        <p:nvPr/>
+      </p:nvGrpSpPr>
+      <p:grpSpPr>
+        <a:xfrm>
+          <a:off x="0" y="0"/>
+          <a:ext cx="0" cy="0"/>
+          <a:chOff x="0" y="0"/>
+          <a:chExt cx="0" cy="0"/>
+        </a:xfrm>
+      </p:grpSpPr>
+      <p:sp>
+        <p:nvSpPr>
+          <p:cNvPr id="3" name="TextBox 2">
+            <a:extLst>
+              <a:ext uri="{FF2B5EF4-FFF2-40B4-BE49-F238E27FC236}">
+                <a16:creationId xmlns:a16="http://schemas.microsoft.com/office/drawing/2014/main" id="{7CD34D09-826D-7A42-04AE-709D83465DD9}"/>
+              </a:ext>
+            </a:extLst>
+          </p:cNvPr>
+          <p:cNvSpPr txBox="1"/>
+          <p:nvPr/>
+        </p:nvSpPr>
+        <p:spPr>
+          <a:xfrm>
+            <a:off x="217714" y="255046"/>
+            <a:ext cx="11756571" cy="355354"/>
+          </a:xfrm>
+          <a:prstGeom prst="rect">
+            <a:avLst/>
+          </a:prstGeom>
+          <a:noFill/>
+        </p:spPr>
+        <p:txBody>
+          <a:bodyPr wrap="square">
+            <a:spAutoFit/>
+          </a:bodyPr>
+          <a:lstStyle/>
+          <a:p>
+            <a:pPr>
+              <a:lnSpc>
+                <a:spcPct val="150000"/>
+              </a:lnSpc>
+              <a:buNone/>
+            </a:pPr>
+            <a:r>
+              <a:rPr kumimoji="0" lang="en-US" altLang="en-US" sz="1300" b="0" i="0" u="none" strike="noStrike" cap="none" normalizeH="0" baseline="0">
+                <a:ln>
+                  <a:noFill/>
+                </a:ln>
+                <a:solidFill>
+                  <a:schemeClr val="tx1"/>
+                </a:solidFill>
+                <a:effectLst/>
+                <a:latin typeface="Arial" panose="020B0604020202020204" pitchFamily="34" charset="0"/>
+              </a:rPr>
+              <a:t>.</a:t>
+            </a:r>
+          </a:p>
+        </p:txBody>
+      </p:sp>
+    </p:spTree>
+    <p:extLst>
+      <p:ext uri="{BB962C8B-B14F-4D97-AF65-F5344CB8AC3E}">
+        <p14:creationId xmlns:p14="http://schemas.microsoft.com/office/powerpoint/2010/main" val="541757729"/>
+      </p:ext>
+    </p:extLst>
+  </p:cSld>
+  <p:clrMapOvr>
+    <a:masterClrMapping/>
+  </p:clrMapOvr>
+</p:sld>
+</file>
+
+<file path=ppt/slides/slide9.xml><?xml version="1.0" encoding="utf-8"?>
+<p:sld xmlns:a="http://schemas.openxmlformats.org/drawingml/2006/main" xmlns:r="http://schemas.openxmlformats.org/officeDocument/2006/relationships" xmlns:p="http://schemas.openxmlformats.org/presentationml/2006/main">
+  <p:cSld>
+    <p:spTree>
+      <p:nvGrpSpPr>
+        <p:cNvPr id="1" name="">
+          <a:extLst>
+            <a:ext uri="{FF2B5EF4-FFF2-40B4-BE49-F238E27FC236}">
+              <a16:creationId xmlns:a16="http://schemas.microsoft.com/office/drawing/2014/main" id="{C1AB4391-423E-2FFD-71C1-67DE2648E00E}"/>
+            </a:ext>
+          </a:extLst>
+        </p:cNvPr>
+        <p:cNvGrpSpPr/>
+        <p:nvPr/>
+      </p:nvGrpSpPr>
+      <p:grpSpPr>
+        <a:xfrm>
+          <a:off x="0" y="0"/>
+          <a:ext cx="0" cy="0"/>
+          <a:chOff x="0" y="0"/>
+          <a:chExt cx="0" cy="0"/>
+        </a:xfrm>
+      </p:grpSpPr>
+      <p:sp>
+        <p:nvSpPr>
+          <p:cNvPr id="3" name="TextBox 2">
+            <a:extLst>
+              <a:ext uri="{FF2B5EF4-FFF2-40B4-BE49-F238E27FC236}">
+                <a16:creationId xmlns:a16="http://schemas.microsoft.com/office/drawing/2014/main" id="{24BB0D2F-1672-8659-B91B-BCFDDC681070}"/>
+              </a:ext>
+            </a:extLst>
+          </p:cNvPr>
+          <p:cNvSpPr txBox="1"/>
+          <p:nvPr/>
+        </p:nvSpPr>
+        <p:spPr>
+          <a:xfrm>
+            <a:off x="217714" y="255046"/>
+            <a:ext cx="11756571" cy="355354"/>
+          </a:xfrm>
+          <a:prstGeom prst="rect">
+            <a:avLst/>
+          </a:prstGeom>
+          <a:noFill/>
+        </p:spPr>
+        <p:txBody>
+          <a:bodyPr wrap="square">
+            <a:spAutoFit/>
+          </a:bodyPr>
+          <a:lstStyle/>
+          <a:p>
+            <a:pPr>
+              <a:lnSpc>
+                <a:spcPct val="150000"/>
+              </a:lnSpc>
+              <a:buNone/>
+            </a:pPr>
+            <a:r>
+              <a:rPr kumimoji="0" lang="en-US" altLang="en-US" sz="1300" b="0" i="0" u="none" strike="noStrike" cap="none" normalizeH="0" baseline="0">
+                <a:ln>
+                  <a:noFill/>
+                </a:ln>
+                <a:solidFill>
+                  <a:schemeClr val="tx1"/>
+                </a:solidFill>
+                <a:effectLst/>
+                <a:latin typeface="Arial" panose="020B0604020202020204" pitchFamily="34" charset="0"/>
+              </a:rPr>
+              <a:t>.</a:t>
+            </a:r>
+          </a:p>
+        </p:txBody>
+      </p:sp>
+    </p:spTree>
+    <p:extLst>
+      <p:ext uri="{BB962C8B-B14F-4D97-AF65-F5344CB8AC3E}">
+        <p14:creationId xmlns:p14="http://schemas.microsoft.com/office/powerpoint/2010/main" val="3347205167"/>
       </p:ext>
     </p:extLst>
   </p:cSld>

</xml_diff>